<commit_message>
Use project title and both authors in paper and deck
Co-Authored-By: Claude Opus 5.5 <noreply@anthropic.com>
</commit_message>
<xml_diff>
--- a/presentation/ReDeEP_presentation.pptx
+++ b/presentation/ReDeEP_presentation.pptx
@@ -118,32 +118,32 @@
   <p:extLst>
     <p:ext uri="{521415D9-36F7-43E2-AB2F-B90AF26B5E84}">
       <p14:sectionLst xmlns:p14="http://schemas.microsoft.com/office/powerpoint/2010/main">
-        <p14:section name="Introduction" id="{7345ca32-136a-05a1-70c8-5ea36144c384}">
+        <p14:section name="Introduction" id="{612beb09-5ff7-1dee-b238-c7eeb06b5a7c}">
           <p14:sldIdLst>
             <p14:sldId id="256"/>
             <p14:sldId id="257"/>
           </p14:sldIdLst>
         </p14:section>
-        <p14:section name="Method" id="{2254f2be-06c6-c733-b8ba-a378262f5100}">
+        <p14:section name="Method" id="{0a4aa9d6-56eb-0c70-9a97-3159870280c3}">
           <p14:sldIdLst>
             <p14:sldId id="258"/>
             <p14:sldId id="259"/>
           </p14:sldIdLst>
         </p14:section>
-        <p14:section name="Results" id="{99b35349-ef7c-07e1-e0c5-bf3b3dcd01de}">
+        <p14:section name="Results" id="{ca6bceef-8223-2fd9-8564-f20be8f82f3e}">
           <p14:sldIdLst>
             <p14:sldId id="260"/>
             <p14:sldId id="261"/>
           </p14:sldIdLst>
         </p14:section>
-        <p14:section name="Extension" id="{14cfce59-0ff9-0b71-492f-78079f426827}">
+        <p14:section name="Extension" id="{c2a04e89-20aa-9536-5dd1-a9a091c907d3}">
           <p14:sldIdLst>
             <p14:sldId id="262"/>
             <p14:sldId id="263"/>
             <p14:sldId id="264"/>
           </p14:sldIdLst>
         </p14:section>
-        <p14:section name="Comparison" id="{01545098-825c-da97-a643-ef2ed439a724}">
+        <p14:section name="Comparison" id="{cb2b1d73-dfc5-0575-5aed-f04c33040aac}">
           <p14:sldIdLst>
             <p14:sldId id="265"/>
             <p14:sldId id="266"/>
@@ -3401,7 +3401,7 @@
                   <a:schemeClr val="bg1"/>
                 </a:solidFill>
               </a:rPr>
-              <a:t>Catching RAG hallucinations from inside the model</a:t>
+              <a:t>ReDeEP: Detecting Hallucination in Retrieval-Augmented Generation via Mechanistic Interpretability</a:t>
             </a:r>
             <a:endParaRPr lang="en-US" sz="3800" dirty="0"/>
           </a:p>
@@ -3439,7 +3439,7 @@
                   <a:schemeClr val="bg2"/>
                 </a:solidFill>
               </a:rPr>
-              <a:t>Reproducing ReDeEP (ICLR 2025) on a 6 GB laptop GPU, and finding its blind spot</a:t>
+              <a:t>A reproduction and robustness study on a 6 GB laptop GPU</a:t>
             </a:r>
             <a:endParaRPr lang="en-US" sz="1800" dirty="0"/>
           </a:p>
@@ -3453,7 +3453,7 @@
                   <a:schemeClr val="bg2"/>
                 </a:solidFill>
               </a:rPr>
-              <a:t>Adithya K</a:t>
+              <a:t>Gourilakshmi S (23BCS21) &amp; Adithya K (23BCS51)</a:t>
             </a:r>
             <a:endParaRPr lang="en-US" sz="1800" dirty="0"/>
           </a:p>

</xml_diff>

<commit_message>
Add GitHub link and full registration numbers to report, paper and slides; links slide
Co-Authored-By: Claude Opus 5.5 <noreply@anthropic.com>
</commit_message>
<xml_diff>
--- a/presentation/ReDeEP_presentation.pptx
+++ b/presentation/ReDeEP_presentation.pptx
@@ -20,9 +20,10 @@
     <p:sldId id="268" r:id="rId14"/>
     <p:sldId id="269" r:id="rId15"/>
     <p:sldId id="270" r:id="rId16"/>
+    <p:sldId id="271" r:id="rId17"/>
   </p:sldIdLst>
   <p:notesMasterIdLst>
-    <p:notesMasterId r:id="rId17"/>
+    <p:notesMasterId r:id="rId18"/>
   </p:notesMasterIdLst>
   <p:sldSz cx="9144000" cy="5143500"/>
   <p:notesSz cx="5143500" cy="9144000"/>
@@ -121,43 +122,44 @@
   <p:extLst>
     <p:ext uri="{521415D9-36F7-43E2-AB2F-B90AF26B5E84}">
       <p14:sectionLst xmlns:p14="http://schemas.microsoft.com/office/powerpoint/2010/main">
-        <p14:section name="Introduction" id="{0a33fdc9-dac5-1572-fb9e-fea19f53a309}">
+        <p14:section name="Introduction" id="{c79bd64c-27bc-bdbc-8c75-f0362f29d03c}">
           <p14:sldIdLst>
             <p14:sldId id="256"/>
             <p14:sldId id="257"/>
           </p14:sldIdLst>
         </p14:section>
-        <p14:section name="Method" id="{6db351fe-7566-5cce-f51b-25dd765461e2}">
+        <p14:section name="Method" id="{4b7ecf74-ee43-f4b6-c00b-6c7edf53cc22}">
           <p14:sldIdLst>
             <p14:sldId id="258"/>
             <p14:sldId id="259"/>
           </p14:sldIdLst>
         </p14:section>
-        <p14:section name="Results" id="{04ab5fb2-a2e3-2818-3a86-ab56e3d56f33}">
+        <p14:section name="Results" id="{1b0669f4-7fe3-da5d-0f58-6ed7f3e6dff0}">
           <p14:sldIdLst>
             <p14:sldId id="260"/>
             <p14:sldId id="261"/>
           </p14:sldIdLst>
         </p14:section>
-        <p14:section name="Extension" id="{bbacbfdd-3eba-d925-77a0-3f52065c93d7}">
+        <p14:section name="Extension" id="{cd230caa-5303-2574-444e-a5b611f00677}">
           <p14:sldIdLst>
             <p14:sldId id="262"/>
             <p14:sldId id="263"/>
             <p14:sldId id="264"/>
           </p14:sldIdLst>
         </p14:section>
-        <p14:section name="Comparison" id="{1a724dab-8b2f-1d31-0ef6-55374084e332}">
+        <p14:section name="Comparison" id="{4a901f6e-55d6-a085-9cf9-f6fa91386f80}">
           <p14:sldIdLst>
             <p14:sldId id="265"/>
           </p14:sldIdLst>
         </p14:section>
-        <p14:section name="Official code" id="{acfb7b87-3d5c-002e-9b83-541114361f04}">
+        <p14:section name="Official code" id="{3fcfa81b-3977-4cef-18da-8f1239ac8867}">
           <p14:sldIdLst>
             <p14:sldId id="266"/>
             <p14:sldId id="267"/>
             <p14:sldId id="268"/>
             <p14:sldId id="269"/>
             <p14:sldId id="270"/>
+            <p14:sldId id="271"/>
           </p14:sldIdLst>
         </p14:section>
       </p14:sectionLst>
@@ -2673,6 +2675,94 @@
 </p:notes>
 </file>
 
+<file path=ppt/notesSlides/notesSlide16.xml><?xml version="1.0" encoding="utf-8"?>
+<p:notes xmlns:a="http://schemas.openxmlformats.org/drawingml/2006/main" xmlns:r="http://schemas.openxmlformats.org/officeDocument/2006/relationships" xmlns:p="http://schemas.openxmlformats.org/presentationml/2006/main">
+  <p:cSld>
+    <p:spTree>
+      <p:nvGrpSpPr>
+        <p:cNvPr id="1" name=""/>
+        <p:cNvGrpSpPr/>
+        <p:nvPr/>
+      </p:nvGrpSpPr>
+      <p:grpSpPr>
+        <a:xfrm>
+          <a:off x="0" y="0"/>
+          <a:ext cx="0" cy="0"/>
+          <a:chOff x="0" y="0"/>
+          <a:chExt cx="0" cy="0"/>
+        </a:xfrm>
+      </p:grpSpPr>
+      <p:sp>
+        <p:nvSpPr>
+          <p:cNvPr id="2" name="Slide Image Placeholder 1"/>
+          <p:cNvSpPr>
+            <a:spLocks noGrp="1" noRot="1" noChangeAspect="1"/>
+          </p:cNvSpPr>
+          <p:nvPr>
+            <p:ph type="sldImg"/>
+          </p:nvPr>
+        </p:nvSpPr>
+        <p:spPr/>
+      </p:sp>
+      <p:sp>
+        <p:nvSpPr>
+          <p:cNvPr id="3" name="Notes Placeholder 2"/>
+          <p:cNvSpPr>
+            <a:spLocks noGrp="1"/>
+          </p:cNvSpPr>
+          <p:nvPr>
+            <p:ph type="body" idx="1"/>
+          </p:nvPr>
+        </p:nvSpPr>
+        <p:spPr/>
+        <p:txBody>
+          <a:bodyPr/>
+          <a:lstStyle/>
+          <a:p>
+            <a:r>
+              <a:rPr lang="en-US" dirty="0"/>
+              <a:t>Questions. All numbers in the report and slides are generated from the result files in the repository.</a:t>
+            </a:r>
+            <a:endParaRPr lang="en-US" dirty="0"/>
+          </a:p>
+        </p:txBody>
+      </p:sp>
+      <p:sp>
+        <p:nvSpPr>
+          <p:cNvPr id="4" name="Slide Number Placeholder 3"/>
+          <p:cNvSpPr>
+            <a:spLocks noGrp="1"/>
+          </p:cNvSpPr>
+          <p:nvPr>
+            <p:ph type="sldNum" sz="quarter" idx="10"/>
+          </p:nvPr>
+        </p:nvSpPr>
+        <p:spPr/>
+        <p:txBody>
+          <a:bodyPr/>
+          <a:lstStyle/>
+          <a:p>
+            <a:fld id="{F7021451-1387-4CA6-816F-3879F97B5CBC}" type="slidenum">
+              <a:rPr lang="en-US"/>
+              <a:t>16</a:t>
+            </a:fld>
+            <a:endParaRPr lang="en-US"/>
+          </a:p>
+        </p:txBody>
+      </p:sp>
+    </p:spTree>
+    <p:extLst>
+      <p:ext uri="{BB962C8B-B14F-4D97-AF65-F5344CB8AC3E}">
+        <p14:creationId xmlns:p14="http://schemas.microsoft.com/office/powerpoint/2010/main" val="1024086991"/>
+      </p:ext>
+    </p:extLst>
+  </p:cSld>
+  <p:clrMapOvr>
+    <a:masterClrMapping/>
+  </p:clrMapOvr>
+</p:notes>
+</file>
+
 <file path=ppt/notesSlides/notesSlide2.xml><?xml version="1.0" encoding="utf-8"?>
 <p:notes xmlns:a="http://schemas.openxmlformats.org/drawingml/2006/main" xmlns:r="http://schemas.openxmlformats.org/officeDocument/2006/relationships" xmlns:p="http://schemas.openxmlformats.org/presentationml/2006/main">
   <p:cSld>
@@ -4080,7 +4170,7 @@
                   <a:schemeClr val="bg2"/>
                 </a:solidFill>
               </a:rPr>
-              <a:t>A reproduction and robustness study on a 6 GB laptop GPU</a:t>
+              <a:t>A reproduction and robustness study  |  IOE-414 Deep Learning, IIIT Kottayam</a:t>
             </a:r>
             <a:endParaRPr lang="en-US" sz="1800" dirty="0"/>
           </a:p>
@@ -4094,7 +4184,21 @@
                   <a:schemeClr val="bg2"/>
                 </a:solidFill>
               </a:rPr>
-              <a:t>Gourilakshmi S (23BCS21) &amp; Adithya K (23BCS51)</a:t>
+              <a:t>Gourilakshmi S (2023BCS0021) &amp; Adithya K (2023BCS0051)</a:t>
+            </a:r>
+            <a:endParaRPr lang="en-US" sz="1800" dirty="0"/>
+          </a:p>
+          <a:p>
+            <a:pPr indent="0" marL="0">
+              <a:buNone/>
+            </a:pPr>
+            <a:r>
+              <a:rPr lang="en-US" sz="1800" dirty="0">
+                <a:solidFill>
+                  <a:schemeClr val="bg2"/>
+                </a:solidFill>
+              </a:rPr>
+              <a:t>github.com/ad1thyaaa/ReDeEP-Reproduction-Robustness</a:t>
             </a:r>
             <a:endParaRPr lang="en-US" sz="1800" dirty="0"/>
           </a:p>
@@ -8510,6 +8614,135 @@
                 </a:solidFill>
               </a:rPr>
               <a:t>Blind to contradicted numbers; AARF's gain does not survive a fair judge</a:t>
+            </a:r>
+            <a:endParaRPr lang="en-US" sz="1800" dirty="0"/>
+          </a:p>
+        </p:txBody>
+      </p:sp>
+    </p:spTree>
+  </p:cSld>
+  <p:clrMapOvr>
+    <a:masterClrMapping/>
+  </p:clrMapOvr>
+</p:sld>
+</file>
+
+<file path=ppt/slides/slide16.xml><?xml version="1.0" encoding="utf-8"?>
+<p:sld xmlns:a="http://schemas.openxmlformats.org/drawingml/2006/main" xmlns:r="http://schemas.openxmlformats.org/officeDocument/2006/relationships" xmlns:p="http://schemas.openxmlformats.org/presentationml/2006/main">
+  <p:cSld name="Slide 16">
+    <p:spTree>
+      <p:nvGrpSpPr>
+        <p:cNvPr id="1" name=""/>
+        <p:cNvGrpSpPr/>
+        <p:nvPr/>
+      </p:nvGrpSpPr>
+      <p:grpSpPr>
+        <a:xfrm>
+          <a:off x="0" y="0"/>
+          <a:ext cx="0" cy="0"/>
+          <a:chOff x="0" y="0"/>
+          <a:chExt cx="0" cy="0"/>
+        </a:xfrm>
+      </p:grpSpPr>
+      <p:sp>
+        <p:nvSpPr>
+          <p:cNvPr id="2" name="Text 0"/>
+          <p:cNvSpPr/>
+          <p:nvPr>
+            <p:ph idx="100" type="title" hasCustomPrompt="1"/>
+          </p:nvPr>
+        </p:nvSpPr>
+        <p:spPr>
+          <a:xfrm>
+            <a:off x="548640" y="1325880"/>
+            <a:ext cx="8046720" cy="1371600"/>
+          </a:xfrm>
+          <a:prstGeom prst="rect">
+            <a:avLst/>
+          </a:prstGeom>
+          <a:noFill/>
+          <a:ln/>
+        </p:spPr>
+        <p:txBody>
+          <a:bodyPr wrap="square" lIns="0" tIns="0" rIns="0" bIns="0" rtlCol="0" anchor="b"/>
+          <a:lstStyle/>
+          <a:p>
+            <a:pPr algn="l" indent="0" marL="0">
+              <a:buNone/>
+            </a:pPr>
+            <a:r>
+              <a:rPr lang="en-US" sz="3800" b="1" dirty="0">
+                <a:solidFill>
+                  <a:schemeClr val="bg1"/>
+                </a:solidFill>
+              </a:rPr>
+              <a:t>Thank you</a:t>
+            </a:r>
+            <a:endParaRPr lang="en-US" sz="3800" dirty="0"/>
+          </a:p>
+        </p:txBody>
+      </p:sp>
+      <p:sp>
+        <p:nvSpPr>
+          <p:cNvPr id="3" name="Text 0"/>
+          <p:cNvSpPr/>
+          <p:nvPr>
+            <p:ph idx="101" type="body" hasCustomPrompt="1"/>
+          </p:nvPr>
+        </p:nvSpPr>
+        <p:spPr>
+          <a:xfrm>
+            <a:off x="548640" y="2880360"/>
+            <a:ext cx="8046720" cy="1097280"/>
+          </a:xfrm>
+          <a:prstGeom prst="rect">
+            <a:avLst/>
+          </a:prstGeom>
+          <a:noFill/>
+          <a:ln/>
+        </p:spPr>
+        <p:txBody>
+          <a:bodyPr wrap="square" lIns="0" tIns="0" rIns="0" bIns="0" rtlCol="0" anchor="t"/>
+          <a:lstStyle/>
+          <a:p>
+            <a:pPr indent="0" marL="0">
+              <a:buNone/>
+            </a:pPr>
+            <a:r>
+              <a:rPr lang="en-US" sz="1800" dirty="0">
+                <a:solidFill>
+                  <a:schemeClr val="bg2"/>
+                </a:solidFill>
+              </a:rPr>
+              <a:t>Code, results and report: github.com/ad1thyaaa/ReDeEP-Reproduction-Robustness</a:t>
+            </a:r>
+            <a:endParaRPr lang="en-US" sz="1800" dirty="0"/>
+          </a:p>
+          <a:p>
+            <a:pPr indent="0" marL="0">
+              <a:buNone/>
+            </a:pPr>
+            <a:r>
+              <a:rPr lang="en-US" sz="1800" dirty="0">
+                <a:solidFill>
+                  <a:schemeClr val="bg2"/>
+                </a:solidFill>
+              </a:rPr>
+              <a:t>Base paper: Sun et al., ReDeEP, ICLR 2025 (doi.org/10.48550/arXiv.2410.11414)</a:t>
+            </a:r>
+            <a:endParaRPr lang="en-US" sz="1800" dirty="0"/>
+          </a:p>
+          <a:p>
+            <a:pPr indent="0" marL="0">
+              <a:buNone/>
+            </a:pPr>
+            <a:r>
+              <a:rPr lang="en-US" sz="1800" dirty="0">
+                <a:solidFill>
+                  <a:schemeClr val="bg2"/>
+                </a:solidFill>
+              </a:rPr>
+              <a:t>Official code and data: github.com/Jeryi-Sun/ReDEeP-ICLR  |  RAGTruth: github.com/ParticleMedia/RAGTruth</a:t>
             </a:r>
             <a:endParaRPr lang="en-US" sz="1800" dirty="0"/>
           </a:p>

</xml_diff>